<commit_message>
Update interview deck to Claude Design V2
</commit_message>
<xml_diff>
--- a/downloads/Mihir_Trivedi_HSN_OR_Dashboard.pptx
+++ b/downloads/Mihir_Trivedi_HSN_OR_Dashboard.pptx
@@ -13,10 +13,9 @@
     <p:sldId id="261" r:id="rId7"/>
     <p:sldId id="262" r:id="rId8"/>
     <p:sldId id="263" r:id="rId9"/>
-    <p:sldId id="264" r:id="rId10"/>
   </p:sldIdLst>
   <p:notesMasterIdLst>
-    <p:notesMasterId r:id="rId11"/>
+    <p:notesMasterId r:id="rId10"/>
   </p:notesMasterIdLst>
   <p:sldSz cx="12192000" cy="6858000"/>
   <p:notesSz cx="6858000" cy="12192000"/>
@@ -1150,94 +1149,6 @@
             <a:fld id="{F7021451-1387-4CA6-816F-3879F97B5CBC}" type="slidenum">
               <a:rPr lang="en-US"/>
               <a:t>8</a:t>
-            </a:fld>
-            <a:endParaRPr lang="en-US"/>
-          </a:p>
-        </p:txBody>
-      </p:sp>
-    </p:spTree>
-    <p:extLst>
-      <p:ext uri="{BB962C8B-B14F-4D97-AF65-F5344CB8AC3E}">
-        <p14:creationId xmlns:p14="http://schemas.microsoft.com/office/powerpoint/2010/main" val="1024086991"/>
-      </p:ext>
-    </p:extLst>
-  </p:cSld>
-  <p:clrMapOvr>
-    <a:masterClrMapping/>
-  </p:clrMapOvr>
-</p:notes>
-</file>
-
-<file path=ppt/notesSlides/notesSlide9.xml><?xml version="1.0" encoding="utf-8"?>
-<p:notes xmlns:a="http://schemas.openxmlformats.org/drawingml/2006/main" xmlns:r="http://schemas.openxmlformats.org/officeDocument/2006/relationships" xmlns:p="http://schemas.openxmlformats.org/presentationml/2006/main">
-  <p:cSld>
-    <p:spTree>
-      <p:nvGrpSpPr>
-        <p:cNvPr id="1" name=""/>
-        <p:cNvGrpSpPr/>
-        <p:nvPr/>
-      </p:nvGrpSpPr>
-      <p:grpSpPr>
-        <a:xfrm>
-          <a:off x="0" y="0"/>
-          <a:ext cx="0" cy="0"/>
-          <a:chOff x="0" y="0"/>
-          <a:chExt cx="0" cy="0"/>
-        </a:xfrm>
-      </p:grpSpPr>
-      <p:sp>
-        <p:nvSpPr>
-          <p:cNvPr id="2" name="Slide Image Placeholder 1"/>
-          <p:cNvSpPr>
-            <a:spLocks noGrp="1" noRot="1" noChangeAspect="1"/>
-          </p:cNvSpPr>
-          <p:nvPr>
-            <p:ph type="sldImg"/>
-          </p:nvPr>
-        </p:nvSpPr>
-        <p:spPr/>
-      </p:sp>
-      <p:sp>
-        <p:nvSpPr>
-          <p:cNvPr id="3" name="Notes Placeholder 2"/>
-          <p:cNvSpPr>
-            <a:spLocks noGrp="1"/>
-          </p:cNvSpPr>
-          <p:nvPr>
-            <p:ph type="body" idx="1"/>
-          </p:nvPr>
-        </p:nvSpPr>
-        <p:spPr/>
-        <p:txBody>
-          <a:bodyPr/>
-          <a:lstStyle/>
-          <a:p>
-            <a:r>
-              <a:rPr lang="en-US" dirty="0"/>
-              <a:t/>
-            </a:r>
-            <a:endParaRPr lang="en-US" dirty="0"/>
-          </a:p>
-        </p:txBody>
-      </p:sp>
-      <p:sp>
-        <p:nvSpPr>
-          <p:cNvPr id="4" name="Slide Number Placeholder 3"/>
-          <p:cNvSpPr>
-            <a:spLocks noGrp="1"/>
-          </p:cNvSpPr>
-          <p:nvPr>
-            <p:ph type="sldNum" sz="quarter" idx="10"/>
-          </p:nvPr>
-        </p:nvSpPr>
-        <p:spPr/>
-        <p:txBody>
-          <a:bodyPr/>
-          <a:lstStyle/>
-          <a:p>
-            <a:fld id="{F7021451-1387-4CA6-816F-3879F97B5CBC}" type="slidenum">
-              <a:rPr lang="en-US"/>
-              <a:t>9</a:t>
             </a:fld>
             <a:endParaRPr lang="en-US"/>
           </a:p>
@@ -1988,55 +1899,6 @@
 </p:sld>
 </file>
 
-<file path=ppt/slides/slide9.xml><?xml version="1.0" encoding="utf-8"?>
-<p:sld xmlns:a="http://schemas.openxmlformats.org/drawingml/2006/main" xmlns:r="http://schemas.openxmlformats.org/officeDocument/2006/relationships" xmlns:p="http://schemas.openxmlformats.org/presentationml/2006/main">
-  <p:cSld name="Slide 9">
-    <p:spTree>
-      <p:nvGrpSpPr>
-        <p:cNvPr id="1" name=""/>
-        <p:cNvGrpSpPr/>
-        <p:nvPr/>
-      </p:nvGrpSpPr>
-      <p:grpSpPr>
-        <a:xfrm>
-          <a:off x="0" y="0"/>
-          <a:ext cx="0" cy="0"/>
-          <a:chOff x="0" y="0"/>
-          <a:chExt cx="0" cy="0"/>
-        </a:xfrm>
-      </p:grpSpPr>
-      <p:pic>
-        <p:nvPicPr>
-          <p:cNvPr id="2" name="Image 0" descr="/tmp/hsn-tools/slide-9.png">    </p:cNvPr>
-          <p:cNvPicPr>
-            <a:picLocks noChangeAspect="1"/>
-          </p:cNvPicPr>
-          <p:nvPr/>
-        </p:nvPicPr>
-        <p:blipFill>
-          <a:blip r:embed="rId1"/>
-          <a:stretch>
-            <a:fillRect/>
-          </a:stretch>
-        </p:blipFill>
-        <p:spPr>
-          <a:xfrm>
-            <a:off x="0" y="0"/>
-            <a:ext cx="12192000" cy="6858000"/>
-          </a:xfrm>
-          <a:prstGeom prst="rect">
-            <a:avLst/>
-          </a:prstGeom>
-        </p:spPr>
-      </p:pic>
-    </p:spTree>
-  </p:cSld>
-  <p:clrMapOvr>
-    <a:masterClrMapping/>
-  </p:clrMapOvr>
-</p:sld>
-</file>
-
 <file path=ppt/theme/theme1.xml><?xml version="1.0" encoding="utf-8"?>
 <a:theme xmlns:a="http://schemas.openxmlformats.org/drawingml/2006/main" name="Office Theme">
   <a:themeElements>

</xml_diff>

<commit_message>
Update presentation and add OR dashboard prototype
</commit_message>
<xml_diff>
--- a/downloads/Mihir_Trivedi_HSN_OR_Dashboard.pptx
+++ b/downloads/Mihir_Trivedi_HSN_OR_Dashboard.pptx
@@ -12,10 +12,9 @@
     <p:sldId id="260" r:id="rId6"/>
     <p:sldId id="261" r:id="rId7"/>
     <p:sldId id="262" r:id="rId8"/>
-    <p:sldId id="263" r:id="rId9"/>
   </p:sldIdLst>
   <p:notesMasterIdLst>
-    <p:notesMasterId r:id="rId10"/>
+    <p:notesMasterId r:id="rId9"/>
   </p:notesMasterIdLst>
   <p:sldSz cx="12192000" cy="6858000"/>
   <p:notesSz cx="6858000" cy="12192000"/>
@@ -1061,94 +1060,6 @@
             <a:fld id="{F7021451-1387-4CA6-816F-3879F97B5CBC}" type="slidenum">
               <a:rPr lang="en-US"/>
               <a:t>7</a:t>
-            </a:fld>
-            <a:endParaRPr lang="en-US"/>
-          </a:p>
-        </p:txBody>
-      </p:sp>
-    </p:spTree>
-    <p:extLst>
-      <p:ext uri="{BB962C8B-B14F-4D97-AF65-F5344CB8AC3E}">
-        <p14:creationId xmlns:p14="http://schemas.microsoft.com/office/powerpoint/2010/main" val="1024086991"/>
-      </p:ext>
-    </p:extLst>
-  </p:cSld>
-  <p:clrMapOvr>
-    <a:masterClrMapping/>
-  </p:clrMapOvr>
-</p:notes>
-</file>
-
-<file path=ppt/notesSlides/notesSlide8.xml><?xml version="1.0" encoding="utf-8"?>
-<p:notes xmlns:a="http://schemas.openxmlformats.org/drawingml/2006/main" xmlns:r="http://schemas.openxmlformats.org/officeDocument/2006/relationships" xmlns:p="http://schemas.openxmlformats.org/presentationml/2006/main">
-  <p:cSld>
-    <p:spTree>
-      <p:nvGrpSpPr>
-        <p:cNvPr id="1" name=""/>
-        <p:cNvGrpSpPr/>
-        <p:nvPr/>
-      </p:nvGrpSpPr>
-      <p:grpSpPr>
-        <a:xfrm>
-          <a:off x="0" y="0"/>
-          <a:ext cx="0" cy="0"/>
-          <a:chOff x="0" y="0"/>
-          <a:chExt cx="0" cy="0"/>
-        </a:xfrm>
-      </p:grpSpPr>
-      <p:sp>
-        <p:nvSpPr>
-          <p:cNvPr id="2" name="Slide Image Placeholder 1"/>
-          <p:cNvSpPr>
-            <a:spLocks noGrp="1" noRot="1" noChangeAspect="1"/>
-          </p:cNvSpPr>
-          <p:nvPr>
-            <p:ph type="sldImg"/>
-          </p:nvPr>
-        </p:nvSpPr>
-        <p:spPr/>
-      </p:sp>
-      <p:sp>
-        <p:nvSpPr>
-          <p:cNvPr id="3" name="Notes Placeholder 2"/>
-          <p:cNvSpPr>
-            <a:spLocks noGrp="1"/>
-          </p:cNvSpPr>
-          <p:nvPr>
-            <p:ph type="body" idx="1"/>
-          </p:nvPr>
-        </p:nvSpPr>
-        <p:spPr/>
-        <p:txBody>
-          <a:bodyPr/>
-          <a:lstStyle/>
-          <a:p>
-            <a:r>
-              <a:rPr lang="en-US" dirty="0"/>
-              <a:t/>
-            </a:r>
-            <a:endParaRPr lang="en-US" dirty="0"/>
-          </a:p>
-        </p:txBody>
-      </p:sp>
-      <p:sp>
-        <p:nvSpPr>
-          <p:cNvPr id="4" name="Slide Number Placeholder 3"/>
-          <p:cNvSpPr>
-            <a:spLocks noGrp="1"/>
-          </p:cNvSpPr>
-          <p:nvPr>
-            <p:ph type="sldNum" sz="quarter" idx="10"/>
-          </p:nvPr>
-        </p:nvSpPr>
-        <p:spPr/>
-        <p:txBody>
-          <a:bodyPr/>
-          <a:lstStyle/>
-          <a:p>
-            <a:fld id="{F7021451-1387-4CA6-816F-3879F97B5CBC}" type="slidenum">
-              <a:rPr lang="en-US"/>
-              <a:t>8</a:t>
             </a:fld>
             <a:endParaRPr lang="en-US"/>
           </a:p>
@@ -1850,55 +1761,6 @@
 </p:sld>
 </file>
 
-<file path=ppt/slides/slide8.xml><?xml version="1.0" encoding="utf-8"?>
-<p:sld xmlns:a="http://schemas.openxmlformats.org/drawingml/2006/main" xmlns:r="http://schemas.openxmlformats.org/officeDocument/2006/relationships" xmlns:p="http://schemas.openxmlformats.org/presentationml/2006/main">
-  <p:cSld name="Slide 8">
-    <p:spTree>
-      <p:nvGrpSpPr>
-        <p:cNvPr id="1" name=""/>
-        <p:cNvGrpSpPr/>
-        <p:nvPr/>
-      </p:nvGrpSpPr>
-      <p:grpSpPr>
-        <a:xfrm>
-          <a:off x="0" y="0"/>
-          <a:ext cx="0" cy="0"/>
-          <a:chOff x="0" y="0"/>
-          <a:chExt cx="0" cy="0"/>
-        </a:xfrm>
-      </p:grpSpPr>
-      <p:pic>
-        <p:nvPicPr>
-          <p:cNvPr id="2" name="Image 0" descr="/tmp/hsn-tools/slide-8.png">    </p:cNvPr>
-          <p:cNvPicPr>
-            <a:picLocks noChangeAspect="1"/>
-          </p:cNvPicPr>
-          <p:nvPr/>
-        </p:nvPicPr>
-        <p:blipFill>
-          <a:blip r:embed="rId1"/>
-          <a:stretch>
-            <a:fillRect/>
-          </a:stretch>
-        </p:blipFill>
-        <p:spPr>
-          <a:xfrm>
-            <a:off x="0" y="0"/>
-            <a:ext cx="12192000" cy="6858000"/>
-          </a:xfrm>
-          <a:prstGeom prst="rect">
-            <a:avLst/>
-          </a:prstGeom>
-        </p:spPr>
-      </p:pic>
-    </p:spTree>
-  </p:cSld>
-  <p:clrMapOvr>
-    <a:masterClrMapping/>
-  </p:clrMapOvr>
-</p:sld>
-</file>
-
 <file path=ppt/theme/theme1.xml><?xml version="1.0" encoding="utf-8"?>
 <a:theme xmlns:a="http://schemas.openxmlformats.org/drawingml/2006/main" name="Office Theme">
   <a:themeElements>

</xml_diff>

<commit_message>
Finalize interactive OR dashboard and PPTX link
</commit_message>
<xml_diff>
--- a/downloads/Mihir_Trivedi_HSN_OR_Dashboard.pptx
+++ b/downloads/Mihir_Trivedi_HSN_OR_Dashboard.pptx
@@ -1085,38 +1085,6 @@
       <p:bgRef idx="1001">
         <a:schemeClr val="bg1"/>
       </p:bgRef>
-    </p:bg>
-    <p:spTree>
-      <p:nvGrpSpPr>
-        <p:cNvPr id="1" name=""/>
-        <p:cNvGrpSpPr/>
-        <p:nvPr/>
-      </p:nvGrpSpPr>
-      <p:grpSpPr>
-        <a:xfrm>
-          <a:off x="0" y="0"/>
-          <a:ext cx="0" cy="0"/>
-          <a:chOff x="0" y="0"/>
-          <a:chExt cx="0" cy="0"/>
-        </a:xfrm>
-      </p:grpSpPr>
-    </p:spTree>
-  </p:cSld>
-  <p:clrMapOvr>
-    <a:masterClrMapping/>
-  </p:clrMapOvr>
-</p:sldLayout>
-</file>
-
-<file path=ppt/slideLayouts/slideLayout2.xml><?xml version="1.0" encoding="utf-8"?>
-<p:sldLayout xmlns:a="http://schemas.openxmlformats.org/drawingml/2006/main" xmlns:r="http://schemas.openxmlformats.org/officeDocument/2006/relationships" xmlns:p="http://schemas.openxmlformats.org/presentationml/2006/main" preserve="1">
-  <p:cSld name="HSN">
-    <p:bg>
-      <p:bgPr>
-        <a:solidFill>
-          <a:srgbClr val="F5F4EF"/>
-        </a:solidFill>
-      </p:bgPr>
     </p:bg>
     <p:spTree>
       <p:nvGrpSpPr>
@@ -1162,7 +1130,6 @@
   <p:clrMap bg1="lt1" tx1="dk1" bg2="lt2" tx2="dk2" accent1="accent1" accent2="accent2" accent3="accent3" accent4="accent4" accent5="accent5" accent6="accent6" hlink="hlink" folHlink="folHlink"/>
   <p:sldLayoutIdLst>
     <p:sldLayoutId id="2147483649" r:id="rId1"/>
-    <p:sldLayoutId id="2147483650" r:id="rId2"/>
   </p:sldLayoutIdLst>
   <p:hf sldNum="0" hdr="0" ftr="0" dt="0"/>
   <p:txStyles>
@@ -1421,6 +1388,13 @@
 <file path=ppt/slides/slide1.xml><?xml version="1.0" encoding="utf-8"?>
 <p:sld xmlns:a="http://schemas.openxmlformats.org/drawingml/2006/main" xmlns:r="http://schemas.openxmlformats.org/officeDocument/2006/relationships" xmlns:p="http://schemas.openxmlformats.org/presentationml/2006/main">
   <p:cSld name="Slide 1">
+    <p:bg>
+      <p:bgPr>
+        <a:solidFill>
+          <a:srgbClr val="F7F6F2"/>
+        </a:solidFill>
+      </p:bgPr>
+    </p:bg>
     <p:spTree>
       <p:nvGrpSpPr>
         <p:cNvPr id="1" name=""/>
@@ -1437,7 +1411,7 @@
       </p:grpSpPr>
       <p:pic>
         <p:nvPicPr>
-          <p:cNvPr id="2" name="Image 0" descr="/tmp/hsn-tools/slide-1.png">    </p:cNvPr>
+          <p:cNvPr id="2" name="Image 0" descr="/var/folders/sg/ny4vn1812lj9b65tr13v5cwr0000gn/T/hsn-pptx-j2VP3d/slide-1.png">    </p:cNvPr>
           <p:cNvPicPr>
             <a:picLocks noChangeAspect="1"/>
           </p:cNvPicPr>
@@ -1470,6 +1444,13 @@
 <file path=ppt/slides/slide2.xml><?xml version="1.0" encoding="utf-8"?>
 <p:sld xmlns:a="http://schemas.openxmlformats.org/drawingml/2006/main" xmlns:r="http://schemas.openxmlformats.org/officeDocument/2006/relationships" xmlns:p="http://schemas.openxmlformats.org/presentationml/2006/main">
   <p:cSld name="Slide 2">
+    <p:bg>
+      <p:bgPr>
+        <a:solidFill>
+          <a:srgbClr val="F7F6F2"/>
+        </a:solidFill>
+      </p:bgPr>
+    </p:bg>
     <p:spTree>
       <p:nvGrpSpPr>
         <p:cNvPr id="1" name=""/>
@@ -1486,7 +1467,7 @@
       </p:grpSpPr>
       <p:pic>
         <p:nvPicPr>
-          <p:cNvPr id="2" name="Image 0" descr="/tmp/hsn-tools/slide-2.png">    </p:cNvPr>
+          <p:cNvPr id="2" name="Image 0" descr="/var/folders/sg/ny4vn1812lj9b65tr13v5cwr0000gn/T/hsn-pptx-j2VP3d/slide-2.png">    </p:cNvPr>
           <p:cNvPicPr>
             <a:picLocks noChangeAspect="1"/>
           </p:cNvPicPr>
@@ -1519,6 +1500,13 @@
 <file path=ppt/slides/slide3.xml><?xml version="1.0" encoding="utf-8"?>
 <p:sld xmlns:a="http://schemas.openxmlformats.org/drawingml/2006/main" xmlns:r="http://schemas.openxmlformats.org/officeDocument/2006/relationships" xmlns:p="http://schemas.openxmlformats.org/presentationml/2006/main">
   <p:cSld name="Slide 3">
+    <p:bg>
+      <p:bgPr>
+        <a:solidFill>
+          <a:srgbClr val="F7F6F2"/>
+        </a:solidFill>
+      </p:bgPr>
+    </p:bg>
     <p:spTree>
       <p:nvGrpSpPr>
         <p:cNvPr id="1" name=""/>
@@ -1535,7 +1523,7 @@
       </p:grpSpPr>
       <p:pic>
         <p:nvPicPr>
-          <p:cNvPr id="2" name="Image 0" descr="/tmp/hsn-tools/slide-3.png">    </p:cNvPr>
+          <p:cNvPr id="2" name="Image 0" descr="/var/folders/sg/ny4vn1812lj9b65tr13v5cwr0000gn/T/hsn-pptx-j2VP3d/slide-3.png">    </p:cNvPr>
           <p:cNvPicPr>
             <a:picLocks noChangeAspect="1"/>
           </p:cNvPicPr>
@@ -1568,6 +1556,13 @@
 <file path=ppt/slides/slide4.xml><?xml version="1.0" encoding="utf-8"?>
 <p:sld xmlns:a="http://schemas.openxmlformats.org/drawingml/2006/main" xmlns:r="http://schemas.openxmlformats.org/officeDocument/2006/relationships" xmlns:p="http://schemas.openxmlformats.org/presentationml/2006/main">
   <p:cSld name="Slide 4">
+    <p:bg>
+      <p:bgPr>
+        <a:solidFill>
+          <a:srgbClr val="F7F6F2"/>
+        </a:solidFill>
+      </p:bgPr>
+    </p:bg>
     <p:spTree>
       <p:nvGrpSpPr>
         <p:cNvPr id="1" name=""/>
@@ -1584,7 +1579,7 @@
       </p:grpSpPr>
       <p:pic>
         <p:nvPicPr>
-          <p:cNvPr id="2" name="Image 0" descr="/tmp/hsn-tools/slide-4.png">    </p:cNvPr>
+          <p:cNvPr id="2" name="Image 0" descr="/var/folders/sg/ny4vn1812lj9b65tr13v5cwr0000gn/T/hsn-pptx-j2VP3d/slide-4.png">    </p:cNvPr>
           <p:cNvPicPr>
             <a:picLocks noChangeAspect="1"/>
           </p:cNvPicPr>
@@ -1617,6 +1612,13 @@
 <file path=ppt/slides/slide5.xml><?xml version="1.0" encoding="utf-8"?>
 <p:sld xmlns:a="http://schemas.openxmlformats.org/drawingml/2006/main" xmlns:r="http://schemas.openxmlformats.org/officeDocument/2006/relationships" xmlns:p="http://schemas.openxmlformats.org/presentationml/2006/main">
   <p:cSld name="Slide 5">
+    <p:bg>
+      <p:bgPr>
+        <a:solidFill>
+          <a:srgbClr val="F7F6F2"/>
+        </a:solidFill>
+      </p:bgPr>
+    </p:bg>
     <p:spTree>
       <p:nvGrpSpPr>
         <p:cNvPr id="1" name=""/>
@@ -1633,7 +1635,7 @@
       </p:grpSpPr>
       <p:pic>
         <p:nvPicPr>
-          <p:cNvPr id="2" name="Image 0" descr="/tmp/hsn-tools/slide-5.png">    </p:cNvPr>
+          <p:cNvPr id="2" name="Image 0" descr="/var/folders/sg/ny4vn1812lj9b65tr13v5cwr0000gn/T/hsn-pptx-j2VP3d/slide-5.png">    </p:cNvPr>
           <p:cNvPicPr>
             <a:picLocks noChangeAspect="1"/>
           </p:cNvPicPr>
@@ -1666,6 +1668,13 @@
 <file path=ppt/slides/slide6.xml><?xml version="1.0" encoding="utf-8"?>
 <p:sld xmlns:a="http://schemas.openxmlformats.org/drawingml/2006/main" xmlns:r="http://schemas.openxmlformats.org/officeDocument/2006/relationships" xmlns:p="http://schemas.openxmlformats.org/presentationml/2006/main">
   <p:cSld name="Slide 6">
+    <p:bg>
+      <p:bgPr>
+        <a:solidFill>
+          <a:srgbClr val="F7F6F2"/>
+        </a:solidFill>
+      </p:bgPr>
+    </p:bg>
     <p:spTree>
       <p:nvGrpSpPr>
         <p:cNvPr id="1" name=""/>
@@ -1682,7 +1691,7 @@
       </p:grpSpPr>
       <p:pic>
         <p:nvPicPr>
-          <p:cNvPr id="2" name="Image 0" descr="/tmp/hsn-tools/slide-6.png">    </p:cNvPr>
+          <p:cNvPr id="2" name="Image 0" descr="/var/folders/sg/ny4vn1812lj9b65tr13v5cwr0000gn/T/hsn-pptx-j2VP3d/slide-6.png">    </p:cNvPr>
           <p:cNvPicPr>
             <a:picLocks noChangeAspect="1"/>
           </p:cNvPicPr>
@@ -1715,6 +1724,13 @@
 <file path=ppt/slides/slide7.xml><?xml version="1.0" encoding="utf-8"?>
 <p:sld xmlns:a="http://schemas.openxmlformats.org/drawingml/2006/main" xmlns:r="http://schemas.openxmlformats.org/officeDocument/2006/relationships" xmlns:p="http://schemas.openxmlformats.org/presentationml/2006/main">
   <p:cSld name="Slide 7">
+    <p:bg>
+      <p:bgPr>
+        <a:solidFill>
+          <a:srgbClr val="F7F6F2"/>
+        </a:solidFill>
+      </p:bgPr>
+    </p:bg>
     <p:spTree>
       <p:nvGrpSpPr>
         <p:cNvPr id="1" name=""/>
@@ -1731,7 +1747,7 @@
       </p:grpSpPr>
       <p:pic>
         <p:nvPicPr>
-          <p:cNvPr id="2" name="Image 0" descr="/tmp/hsn-tools/slide-7.png">    </p:cNvPr>
+          <p:cNvPr id="2" name="Image 0" descr="/var/folders/sg/ny4vn1812lj9b65tr13v5cwr0000gn/T/hsn-pptx-j2VP3d/slide-7.png">    </p:cNvPr>
           <p:cNvPicPr>
             <a:picLocks noChangeAspect="1"/>
           </p:cNvPicPr>
@@ -1753,6 +1769,37 @@
           </a:prstGeom>
         </p:spPr>
       </p:pic>
+      <p:sp>
+        <p:nvSpPr>
+          <p:cNvPr id="3" name="Shape 0">
+            <a:hlinkClick r:id="rId2" tooltip="Explore Interactive OR Dashboard"/>
+          </p:cNvPr>
+          <p:cNvSpPr/>
+          <p:nvPr/>
+        </p:nvSpPr>
+        <p:spPr>
+          <a:xfrm>
+            <a:off x="762000" y="5213350"/>
+            <a:ext cx="3946525" cy="628650"/>
+          </a:xfrm>
+          <a:prstGeom prst="rect">
+            <a:avLst/>
+          </a:prstGeom>
+          <a:solidFill>
+            <a:srgbClr val="FFFFFF">
+              <a:alpha val="0"/>
+            </a:srgbClr>
+          </a:solidFill>
+          <a:ln w="12700">
+            <a:solidFill>
+              <a:srgbClr val="FFFFFF">
+                <a:alpha val="0"/>
+              </a:srgbClr>
+            </a:solidFill>
+            <a:prstDash val="solid"/>
+          </a:ln>
+        </p:spPr>
+      </p:sp>
     </p:spTree>
   </p:cSld>
   <p:clrMapOvr>

</xml_diff>

<commit_message>
Fix PowerPoint dashboard CTA hyperlink
</commit_message>
<xml_diff>
--- a/downloads/Mihir_Trivedi_HSN_OR_Dashboard.pptx
+++ b/downloads/Mihir_Trivedi_HSN_OR_Dashboard.pptx
@@ -1411,7 +1411,7 @@
       </p:grpSpPr>
       <p:pic>
         <p:nvPicPr>
-          <p:cNvPr id="2" name="Image 0" descr="/var/folders/sg/ny4vn1812lj9b65tr13v5cwr0000gn/T/hsn-pptx-j2VP3d/slide-1.png">    </p:cNvPr>
+          <p:cNvPr id="2" name="Image 0" descr="/var/folders/sg/ny4vn1812lj9b65tr13v5cwr0000gn/T/hsn-pptx-j7Cuzy/slide-1.png">    </p:cNvPr>
           <p:cNvPicPr>
             <a:picLocks noChangeAspect="1"/>
           </p:cNvPicPr>
@@ -1467,7 +1467,7 @@
       </p:grpSpPr>
       <p:pic>
         <p:nvPicPr>
-          <p:cNvPr id="2" name="Image 0" descr="/var/folders/sg/ny4vn1812lj9b65tr13v5cwr0000gn/T/hsn-pptx-j2VP3d/slide-2.png">    </p:cNvPr>
+          <p:cNvPr id="2" name="Image 0" descr="/var/folders/sg/ny4vn1812lj9b65tr13v5cwr0000gn/T/hsn-pptx-j7Cuzy/slide-2.png">    </p:cNvPr>
           <p:cNvPicPr>
             <a:picLocks noChangeAspect="1"/>
           </p:cNvPicPr>
@@ -1523,7 +1523,7 @@
       </p:grpSpPr>
       <p:pic>
         <p:nvPicPr>
-          <p:cNvPr id="2" name="Image 0" descr="/var/folders/sg/ny4vn1812lj9b65tr13v5cwr0000gn/T/hsn-pptx-j2VP3d/slide-3.png">    </p:cNvPr>
+          <p:cNvPr id="2" name="Image 0" descr="/var/folders/sg/ny4vn1812lj9b65tr13v5cwr0000gn/T/hsn-pptx-j7Cuzy/slide-3.png">    </p:cNvPr>
           <p:cNvPicPr>
             <a:picLocks noChangeAspect="1"/>
           </p:cNvPicPr>
@@ -1579,7 +1579,7 @@
       </p:grpSpPr>
       <p:pic>
         <p:nvPicPr>
-          <p:cNvPr id="2" name="Image 0" descr="/var/folders/sg/ny4vn1812lj9b65tr13v5cwr0000gn/T/hsn-pptx-j2VP3d/slide-4.png">    </p:cNvPr>
+          <p:cNvPr id="2" name="Image 0" descr="/var/folders/sg/ny4vn1812lj9b65tr13v5cwr0000gn/T/hsn-pptx-j7Cuzy/slide-4.png">    </p:cNvPr>
           <p:cNvPicPr>
             <a:picLocks noChangeAspect="1"/>
           </p:cNvPicPr>
@@ -1635,7 +1635,7 @@
       </p:grpSpPr>
       <p:pic>
         <p:nvPicPr>
-          <p:cNvPr id="2" name="Image 0" descr="/var/folders/sg/ny4vn1812lj9b65tr13v5cwr0000gn/T/hsn-pptx-j2VP3d/slide-5.png">    </p:cNvPr>
+          <p:cNvPr id="2" name="Image 0" descr="/var/folders/sg/ny4vn1812lj9b65tr13v5cwr0000gn/T/hsn-pptx-j7Cuzy/slide-5.png">    </p:cNvPr>
           <p:cNvPicPr>
             <a:picLocks noChangeAspect="1"/>
           </p:cNvPicPr>
@@ -1691,7 +1691,7 @@
       </p:grpSpPr>
       <p:pic>
         <p:nvPicPr>
-          <p:cNvPr id="2" name="Image 0" descr="/var/folders/sg/ny4vn1812lj9b65tr13v5cwr0000gn/T/hsn-pptx-j2VP3d/slide-6.png">    </p:cNvPr>
+          <p:cNvPr id="2" name="Image 0" descr="/var/folders/sg/ny4vn1812lj9b65tr13v5cwr0000gn/T/hsn-pptx-j7Cuzy/slide-6.png">    </p:cNvPr>
           <p:cNvPicPr>
             <a:picLocks noChangeAspect="1"/>
           </p:cNvPicPr>
@@ -1747,7 +1747,7 @@
       </p:grpSpPr>
       <p:pic>
         <p:nvPicPr>
-          <p:cNvPr id="2" name="Image 0" descr="/var/folders/sg/ny4vn1812lj9b65tr13v5cwr0000gn/T/hsn-pptx-j2VP3d/slide-7.png">    </p:cNvPr>
+          <p:cNvPr id="2" name="Image 0" descr="/var/folders/sg/ny4vn1812lj9b65tr13v5cwr0000gn/T/hsn-pptx-j7Cuzy/slide-7.png">    </p:cNvPr>
           <p:cNvPicPr>
             <a:picLocks noChangeAspect="1"/>
           </p:cNvPicPr>
@@ -1769,14 +1769,22 @@
           </a:prstGeom>
         </p:spPr>
       </p:pic>
-      <p:sp>
-        <p:nvSpPr>
-          <p:cNvPr id="3" name="Shape 0">
-            <a:hlinkClick r:id="rId2" tooltip="Explore Interactive OR Dashboard"/>
+      <p:pic>
+        <p:nvPicPr>
+          <p:cNvPr id="3" name="Image 1" descr="Explore Interactive OR Dashboard">
+            <a:hlinkClick r:id="rId3" tooltip="Explore Interactive OR Dashboard"/>
           </p:cNvPr>
-          <p:cNvSpPr/>
+          <p:cNvPicPr>
+            <a:picLocks noChangeAspect="1"/>
+          </p:cNvPicPr>
           <p:nvPr/>
-        </p:nvSpPr>
+        </p:nvPicPr>
+        <p:blipFill>
+          <a:blip r:embed="rId2"/>
+          <a:stretch>
+            <a:fillRect/>
+          </a:stretch>
+        </p:blipFill>
         <p:spPr>
           <a:xfrm>
             <a:off x="762000" y="5213350"/>
@@ -1785,21 +1793,8 @@
           <a:prstGeom prst="rect">
             <a:avLst/>
           </a:prstGeom>
-          <a:solidFill>
-            <a:srgbClr val="FFFFFF">
-              <a:alpha val="0"/>
-            </a:srgbClr>
-          </a:solidFill>
-          <a:ln w="12700">
-            <a:solidFill>
-              <a:srgbClr val="FFFFFF">
-                <a:alpha val="0"/>
-              </a:srgbClr>
-            </a:solidFill>
-            <a:prstDash val="solid"/>
-          </a:ln>
         </p:spPr>
-      </p:sp>
+      </p:pic>
     </p:spTree>
   </p:cSld>
   <p:clrMapOvr>

</xml_diff>

<commit_message>
Add clickable text hyperlink to PowerPoint dashboard CTA
PowerPoint only follows picture hyperlinks in Slide Show, so overlay an
invisible text box on the last-slide CTA whose shape and text run both
link to the deployed dashboard.

Co-Authored-By: Claude Opus 5.5 (1M context) <noreply@anthropic.com>
</commit_message>
<xml_diff>
--- a/downloads/Mihir_Trivedi_HSN_OR_Dashboard.pptx
+++ b/downloads/Mihir_Trivedi_HSN_OR_Dashboard.pptx
@@ -1411,7 +1411,7 @@
       </p:grpSpPr>
       <p:pic>
         <p:nvPicPr>
-          <p:cNvPr id="2" name="Image 0" descr="/var/folders/sg/ny4vn1812lj9b65tr13v5cwr0000gn/T/hsn-pptx-j7Cuzy/slide-1.png">    </p:cNvPr>
+          <p:cNvPr id="2" name="Image 0" descr="/var/folders/sg/ny4vn1812lj9b65tr13v5cwr0000gn/T/hsn-pptx-kRW4fZ/slide-1.png">    </p:cNvPr>
           <p:cNvPicPr>
             <a:picLocks noChangeAspect="1"/>
           </p:cNvPicPr>
@@ -1467,7 +1467,7 @@
       </p:grpSpPr>
       <p:pic>
         <p:nvPicPr>
-          <p:cNvPr id="2" name="Image 0" descr="/var/folders/sg/ny4vn1812lj9b65tr13v5cwr0000gn/T/hsn-pptx-j7Cuzy/slide-2.png">    </p:cNvPr>
+          <p:cNvPr id="2" name="Image 0" descr="/var/folders/sg/ny4vn1812lj9b65tr13v5cwr0000gn/T/hsn-pptx-kRW4fZ/slide-2.png">    </p:cNvPr>
           <p:cNvPicPr>
             <a:picLocks noChangeAspect="1"/>
           </p:cNvPicPr>
@@ -1523,7 +1523,7 @@
       </p:grpSpPr>
       <p:pic>
         <p:nvPicPr>
-          <p:cNvPr id="2" name="Image 0" descr="/var/folders/sg/ny4vn1812lj9b65tr13v5cwr0000gn/T/hsn-pptx-j7Cuzy/slide-3.png">    </p:cNvPr>
+          <p:cNvPr id="2" name="Image 0" descr="/var/folders/sg/ny4vn1812lj9b65tr13v5cwr0000gn/T/hsn-pptx-kRW4fZ/slide-3.png">    </p:cNvPr>
           <p:cNvPicPr>
             <a:picLocks noChangeAspect="1"/>
           </p:cNvPicPr>
@@ -1579,7 +1579,7 @@
       </p:grpSpPr>
       <p:pic>
         <p:nvPicPr>
-          <p:cNvPr id="2" name="Image 0" descr="/var/folders/sg/ny4vn1812lj9b65tr13v5cwr0000gn/T/hsn-pptx-j7Cuzy/slide-4.png">    </p:cNvPr>
+          <p:cNvPr id="2" name="Image 0" descr="/var/folders/sg/ny4vn1812lj9b65tr13v5cwr0000gn/T/hsn-pptx-kRW4fZ/slide-4.png">    </p:cNvPr>
           <p:cNvPicPr>
             <a:picLocks noChangeAspect="1"/>
           </p:cNvPicPr>
@@ -1635,7 +1635,7 @@
       </p:grpSpPr>
       <p:pic>
         <p:nvPicPr>
-          <p:cNvPr id="2" name="Image 0" descr="/var/folders/sg/ny4vn1812lj9b65tr13v5cwr0000gn/T/hsn-pptx-j7Cuzy/slide-5.png">    </p:cNvPr>
+          <p:cNvPr id="2" name="Image 0" descr="/var/folders/sg/ny4vn1812lj9b65tr13v5cwr0000gn/T/hsn-pptx-kRW4fZ/slide-5.png">    </p:cNvPr>
           <p:cNvPicPr>
             <a:picLocks noChangeAspect="1"/>
           </p:cNvPicPr>
@@ -1691,7 +1691,7 @@
       </p:grpSpPr>
       <p:pic>
         <p:nvPicPr>
-          <p:cNvPr id="2" name="Image 0" descr="/var/folders/sg/ny4vn1812lj9b65tr13v5cwr0000gn/T/hsn-pptx-j7Cuzy/slide-6.png">    </p:cNvPr>
+          <p:cNvPr id="2" name="Image 0" descr="/var/folders/sg/ny4vn1812lj9b65tr13v5cwr0000gn/T/hsn-pptx-kRW4fZ/slide-6.png">    </p:cNvPr>
           <p:cNvPicPr>
             <a:picLocks noChangeAspect="1"/>
           </p:cNvPicPr>
@@ -1747,7 +1747,7 @@
       </p:grpSpPr>
       <p:pic>
         <p:nvPicPr>
-          <p:cNvPr id="2" name="Image 0" descr="/var/folders/sg/ny4vn1812lj9b65tr13v5cwr0000gn/T/hsn-pptx-j7Cuzy/slide-7.png">    </p:cNvPr>
+          <p:cNvPr id="2" name="Image 0" descr="/var/folders/sg/ny4vn1812lj9b65tr13v5cwr0000gn/T/hsn-pptx-kRW4fZ/slide-7.png">    </p:cNvPr>
           <p:cNvPicPr>
             <a:picLocks noChangeAspect="1"/>
           </p:cNvPicPr>
@@ -1795,6 +1795,57 @@
           </a:prstGeom>
         </p:spPr>
       </p:pic>
+      <p:sp>
+        <p:nvSpPr>
+          <p:cNvPr id="4" name="Dashboard CTA link">
+            <a:hlinkClick r:id="rId4" tooltip="Explore Interactive OR Dashboard"/>
+          </p:cNvPr>
+          <p:cNvSpPr/>
+          <p:nvPr/>
+        </p:nvSpPr>
+        <p:spPr>
+          <a:xfrm>
+            <a:off x="762000" y="5213350"/>
+            <a:ext cx="3946525" cy="628650"/>
+          </a:xfrm>
+          <a:prstGeom prst="rect">
+            <a:avLst/>
+          </a:prstGeom>
+          <a:solidFill>
+            <a:srgbClr val="FFFFFF">
+              <a:alpha val="0"/>
+            </a:srgbClr>
+          </a:solidFill>
+          <a:ln/>
+        </p:spPr>
+        <p:txBody>
+          <a:bodyPr wrap="square" lIns="0" tIns="0" rIns="0" bIns="0" rtlCol="0" anchor="ctr"/>
+          <a:lstStyle/>
+          <a:p>
+            <a:pPr algn="ctr" indent="0" marL="0">
+              <a:buNone/>
+            </a:pPr>
+            <a:r>
+              <a:rPr lang="en-US" sz="1600" u="none" dirty="0">
+                <a:solidFill>
+                  <a:srgbClr val="FFFFFF">
+                    <a:alpha val="0"/>
+                  </a:srgbClr>
+                </a:solidFill>
+                <a:hlinkClick r:id="rId4" invalidUrl="" action="" tgtFrame="" tooltip="Explore Interactive OR Dashboard" history="1" highlightClick="0" endSnd="0">
+                  <a:extLst>
+                    <a:ext uri="{A12FA001-AC4F-418D-AE19-62706E023703}">
+                      <ahyp:hlinkClr xmlns:ahyp="http://schemas.microsoft.com/office/drawing/2018/hyperlinkcolor" val="tx"/>
+                    </a:ext>
+                  </a:extLst>
+                </a:hlinkClick>
+              </a:rPr>
+              <a:t>Explore Interactive OR Dashboard</a:t>
+            </a:r>
+            <a:endParaRPr lang="en-US" sz="1600" dirty="0"/>
+          </a:p>
+        </p:txBody>
+      </p:sp>
     </p:spTree>
   </p:cSld>
   <p:clrMapOvr>

</xml_diff>